<commit_message>
Add Singh to election image
</commit_message>
<xml_diff>
--- a/2025Canada/banner.pptx
+++ b/2025Canada/banner.pptx
@@ -5,12 +5,13 @@
     <p:sldMasterId id="2147483660" r:id="rId1"/>
   </p:sldMasterIdLst>
   <p:notesMasterIdLst>
-    <p:notesMasterId r:id="rId5"/>
+    <p:notesMasterId r:id="rId6"/>
   </p:notesMasterIdLst>
   <p:sldIdLst>
     <p:sldId id="256" r:id="rId2"/>
     <p:sldId id="257" r:id="rId3"/>
     <p:sldId id="258" r:id="rId4"/>
+    <p:sldId id="259" r:id="rId5"/>
   </p:sldIdLst>
   <p:sldSz cx="10799763" cy="5759450"/>
   <p:notesSz cx="6858000" cy="9144000"/>
@@ -199,7 +200,7 @@
           <a:p>
             <a:fld id="{977D88BF-532D-45F8-8705-6DC58283B8DF}" type="datetimeFigureOut">
               <a:rPr lang="en-CA" smtClean="0"/>
-              <a:t>2025-08-22</a:t>
+              <a:t>2025-09-15</a:t>
             </a:fld>
             <a:endParaRPr lang="en-CA"/>
           </a:p>
@@ -687,7 +688,7 @@
           <a:p>
             <a:fld id="{5899F6B3-811F-4FB0-8A8F-1ECB6174A6D5}" type="datetimeFigureOut">
               <a:rPr lang="en-CA" smtClean="0"/>
-              <a:t>2025-08-22</a:t>
+              <a:t>2025-09-15</a:t>
             </a:fld>
             <a:endParaRPr lang="en-CA"/>
           </a:p>
@@ -857,7 +858,7 @@
           <a:p>
             <a:fld id="{5899F6B3-811F-4FB0-8A8F-1ECB6174A6D5}" type="datetimeFigureOut">
               <a:rPr lang="en-CA" smtClean="0"/>
-              <a:t>2025-08-22</a:t>
+              <a:t>2025-09-15</a:t>
             </a:fld>
             <a:endParaRPr lang="en-CA"/>
           </a:p>
@@ -1037,7 +1038,7 @@
           <a:p>
             <a:fld id="{5899F6B3-811F-4FB0-8A8F-1ECB6174A6D5}" type="datetimeFigureOut">
               <a:rPr lang="en-CA" smtClean="0"/>
-              <a:t>2025-08-22</a:t>
+              <a:t>2025-09-15</a:t>
             </a:fld>
             <a:endParaRPr lang="en-CA"/>
           </a:p>
@@ -1207,7 +1208,7 @@
           <a:p>
             <a:fld id="{5899F6B3-811F-4FB0-8A8F-1ECB6174A6D5}" type="datetimeFigureOut">
               <a:rPr lang="en-CA" smtClean="0"/>
-              <a:t>2025-08-22</a:t>
+              <a:t>2025-09-15</a:t>
             </a:fld>
             <a:endParaRPr lang="en-CA"/>
           </a:p>
@@ -1453,7 +1454,7 @@
           <a:p>
             <a:fld id="{5899F6B3-811F-4FB0-8A8F-1ECB6174A6D5}" type="datetimeFigureOut">
               <a:rPr lang="en-CA" smtClean="0"/>
-              <a:t>2025-08-22</a:t>
+              <a:t>2025-09-15</a:t>
             </a:fld>
             <a:endParaRPr lang="en-CA"/>
           </a:p>
@@ -1685,7 +1686,7 @@
           <a:p>
             <a:fld id="{5899F6B3-811F-4FB0-8A8F-1ECB6174A6D5}" type="datetimeFigureOut">
               <a:rPr lang="en-CA" smtClean="0"/>
-              <a:t>2025-08-22</a:t>
+              <a:t>2025-09-15</a:t>
             </a:fld>
             <a:endParaRPr lang="en-CA"/>
           </a:p>
@@ -2052,7 +2053,7 @@
           <a:p>
             <a:fld id="{5899F6B3-811F-4FB0-8A8F-1ECB6174A6D5}" type="datetimeFigureOut">
               <a:rPr lang="en-CA" smtClean="0"/>
-              <a:t>2025-08-22</a:t>
+              <a:t>2025-09-15</a:t>
             </a:fld>
             <a:endParaRPr lang="en-CA"/>
           </a:p>
@@ -2170,7 +2171,7 @@
           <a:p>
             <a:fld id="{5899F6B3-811F-4FB0-8A8F-1ECB6174A6D5}" type="datetimeFigureOut">
               <a:rPr lang="en-CA" smtClean="0"/>
-              <a:t>2025-08-22</a:t>
+              <a:t>2025-09-15</a:t>
             </a:fld>
             <a:endParaRPr lang="en-CA"/>
           </a:p>
@@ -2265,7 +2266,7 @@
           <a:p>
             <a:fld id="{5899F6B3-811F-4FB0-8A8F-1ECB6174A6D5}" type="datetimeFigureOut">
               <a:rPr lang="en-CA" smtClean="0"/>
-              <a:t>2025-08-22</a:t>
+              <a:t>2025-09-15</a:t>
             </a:fld>
             <a:endParaRPr lang="en-CA"/>
           </a:p>
@@ -2542,7 +2543,7 @@
           <a:p>
             <a:fld id="{5899F6B3-811F-4FB0-8A8F-1ECB6174A6D5}" type="datetimeFigureOut">
               <a:rPr lang="en-CA" smtClean="0"/>
-              <a:t>2025-08-22</a:t>
+              <a:t>2025-09-15</a:t>
             </a:fld>
             <a:endParaRPr lang="en-CA"/>
           </a:p>
@@ -2799,7 +2800,7 @@
           <a:p>
             <a:fld id="{5899F6B3-811F-4FB0-8A8F-1ECB6174A6D5}" type="datetimeFigureOut">
               <a:rPr lang="en-CA" smtClean="0"/>
-              <a:t>2025-08-22</a:t>
+              <a:t>2025-09-15</a:t>
             </a:fld>
             <a:endParaRPr lang="en-CA"/>
           </a:p>
@@ -3012,7 +3013,7 @@
           <a:p>
             <a:fld id="{5899F6B3-811F-4FB0-8A8F-1ECB6174A6D5}" type="datetimeFigureOut">
               <a:rPr lang="en-CA" smtClean="0"/>
-              <a:t>2025-08-22</a:t>
+              <a:t>2025-09-15</a:t>
             </a:fld>
             <a:endParaRPr lang="en-CA"/>
           </a:p>
@@ -4059,6 +4060,153 @@
     <p:extLst>
       <p:ext uri="{BB962C8B-B14F-4D97-AF65-F5344CB8AC3E}">
         <p14:creationId xmlns:p14="http://schemas.microsoft.com/office/powerpoint/2010/main" val="3726788691"/>
+      </p:ext>
+    </p:extLst>
+  </p:cSld>
+  <p:clrMapOvr>
+    <a:masterClrMapping/>
+  </p:clrMapOvr>
+</p:sld>
+</file>
+
+<file path=ppt/slides/slide4.xml><?xml version="1.0" encoding="utf-8"?>
+<p:sld xmlns:a="http://schemas.openxmlformats.org/drawingml/2006/main" xmlns:r="http://schemas.openxmlformats.org/officeDocument/2006/relationships" xmlns:p="http://schemas.openxmlformats.org/presentationml/2006/main">
+  <p:cSld>
+    <p:spTree>
+      <p:nvGrpSpPr>
+        <p:cNvPr id="1" name="">
+          <a:extLst>
+            <a:ext uri="{FF2B5EF4-FFF2-40B4-BE49-F238E27FC236}">
+              <a16:creationId xmlns:a16="http://schemas.microsoft.com/office/drawing/2014/main" id="{9ACC3D35-4477-43A8-6815-11FF711A1599}"/>
+            </a:ext>
+          </a:extLst>
+        </p:cNvPr>
+        <p:cNvGrpSpPr/>
+        <p:nvPr/>
+      </p:nvGrpSpPr>
+      <p:grpSpPr>
+        <a:xfrm>
+          <a:off x="0" y="0"/>
+          <a:ext cx="0" cy="0"/>
+          <a:chOff x="0" y="0"/>
+          <a:chExt cx="0" cy="0"/>
+        </a:xfrm>
+      </p:grpSpPr>
+      <p:pic>
+        <p:nvPicPr>
+          <p:cNvPr id="7" name="Picture 6" descr="A person in a suit and tie&#10;&#10;AI-generated content may be incorrect.">
+            <a:extLst>
+              <a:ext uri="{FF2B5EF4-FFF2-40B4-BE49-F238E27FC236}">
+                <a16:creationId xmlns:a16="http://schemas.microsoft.com/office/drawing/2014/main" id="{883E01D2-9793-EE0F-D24E-B84C6F79A5A6}"/>
+              </a:ext>
+            </a:extLst>
+          </p:cNvPr>
+          <p:cNvPicPr>
+            <a:picLocks noChangeAspect="1"/>
+          </p:cNvPicPr>
+          <p:nvPr/>
+        </p:nvPicPr>
+        <p:blipFill rotWithShape="1">
+          <a:blip r:embed="rId2">
+            <a:extLst>
+              <a:ext uri="{28A0092B-C50C-407E-A947-70E740481C1C}">
+                <a14:useLocalDpi xmlns:a14="http://schemas.microsoft.com/office/drawing/2010/main" val="0"/>
+              </a:ext>
+            </a:extLst>
+          </a:blip>
+          <a:srcRect l="35228" t="2" r="42270" b="48932"/>
+          <a:stretch>
+            <a:fillRect/>
+          </a:stretch>
+        </p:blipFill>
+        <p:spPr>
+          <a:xfrm>
+            <a:off x="7199763" y="0"/>
+            <a:ext cx="3600000" cy="5759450"/>
+          </a:xfrm>
+          <a:prstGeom prst="rect">
+            <a:avLst/>
+          </a:prstGeom>
+        </p:spPr>
+      </p:pic>
+      <p:pic>
+        <p:nvPicPr>
+          <p:cNvPr id="5" name="Picture 4" descr="A person in a suit and tie&#10;&#10;AI-generated content may be incorrect.">
+            <a:extLst>
+              <a:ext uri="{FF2B5EF4-FFF2-40B4-BE49-F238E27FC236}">
+                <a16:creationId xmlns:a16="http://schemas.microsoft.com/office/drawing/2014/main" id="{01E3BE52-0C37-CD39-6D37-C10774BDC1DB}"/>
+              </a:ext>
+            </a:extLst>
+          </p:cNvPr>
+          <p:cNvPicPr>
+            <a:picLocks noChangeAspect="1"/>
+          </p:cNvPicPr>
+          <p:nvPr/>
+        </p:nvPicPr>
+        <p:blipFill rotWithShape="1">
+          <a:blip r:embed="rId3">
+            <a:extLst>
+              <a:ext uri="{28A0092B-C50C-407E-A947-70E740481C1C}">
+                <a14:useLocalDpi xmlns:a14="http://schemas.microsoft.com/office/drawing/2010/main" val="0"/>
+              </a:ext>
+            </a:extLst>
+          </a:blip>
+          <a:srcRect l="30802" t="252" r="32455" b="5703"/>
+          <a:stretch>
+            <a:fillRect/>
+          </a:stretch>
+        </p:blipFill>
+        <p:spPr>
+          <a:xfrm>
+            <a:off x="3599762" y="0"/>
+            <a:ext cx="3600000" cy="5759450"/>
+          </a:xfrm>
+          <a:prstGeom prst="rect">
+            <a:avLst/>
+          </a:prstGeom>
+        </p:spPr>
+      </p:pic>
+      <p:pic>
+        <p:nvPicPr>
+          <p:cNvPr id="3" name="Picture 2" descr="A person in a suit standing in front of a group of people&#10;&#10;AI-generated content may be incorrect.">
+            <a:extLst>
+              <a:ext uri="{FF2B5EF4-FFF2-40B4-BE49-F238E27FC236}">
+                <a16:creationId xmlns:a16="http://schemas.microsoft.com/office/drawing/2014/main" id="{08739DA6-A861-E3DF-F9AF-BEA28D996631}"/>
+              </a:ext>
+            </a:extLst>
+          </p:cNvPr>
+          <p:cNvPicPr>
+            <a:picLocks noChangeAspect="1"/>
+          </p:cNvPicPr>
+          <p:nvPr/>
+        </p:nvPicPr>
+        <p:blipFill rotWithShape="1">
+          <a:blip r:embed="rId4">
+            <a:extLst>
+              <a:ext uri="{28A0092B-C50C-407E-A947-70E740481C1C}">
+                <a14:useLocalDpi xmlns:a14="http://schemas.microsoft.com/office/drawing/2010/main" val="0"/>
+              </a:ext>
+            </a:extLst>
+          </a:blip>
+          <a:srcRect l="43109" t="5872" r="42225" b="58934"/>
+          <a:stretch>
+            <a:fillRect/>
+          </a:stretch>
+        </p:blipFill>
+        <p:spPr>
+          <a:xfrm>
+            <a:off x="-238" y="0"/>
+            <a:ext cx="3600000" cy="5759450"/>
+          </a:xfrm>
+          <a:prstGeom prst="rect">
+            <a:avLst/>
+          </a:prstGeom>
+        </p:spPr>
+      </p:pic>
+    </p:spTree>
+    <p:extLst>
+      <p:ext uri="{BB962C8B-B14F-4D97-AF65-F5344CB8AC3E}">
+        <p14:creationId xmlns:p14="http://schemas.microsoft.com/office/powerpoint/2010/main" val="1342891498"/>
       </p:ext>
     </p:extLst>
   </p:cSld>

</xml_diff>

<commit_message>
Add achievements + ending details
</commit_message>
<xml_diff>
--- a/2025Canada/banner.pptx
+++ b/2025Canada/banner.pptx
@@ -5,13 +5,16 @@
     <p:sldMasterId id="2147483660" r:id="rId1"/>
   </p:sldMasterIdLst>
   <p:notesMasterIdLst>
-    <p:notesMasterId r:id="rId6"/>
+    <p:notesMasterId r:id="rId9"/>
   </p:notesMasterIdLst>
   <p:sldIdLst>
     <p:sldId id="256" r:id="rId2"/>
     <p:sldId id="257" r:id="rId3"/>
     <p:sldId id="258" r:id="rId4"/>
     <p:sldId id="259" r:id="rId5"/>
+    <p:sldId id="260" r:id="rId6"/>
+    <p:sldId id="261" r:id="rId7"/>
+    <p:sldId id="262" r:id="rId8"/>
   </p:sldIdLst>
   <p:sldSz cx="10799763" cy="5759450"/>
   <p:notesSz cx="6858000" cy="9144000"/>
@@ -4207,6 +4210,213 @@
     <p:extLst>
       <p:ext uri="{BB962C8B-B14F-4D97-AF65-F5344CB8AC3E}">
         <p14:creationId xmlns:p14="http://schemas.microsoft.com/office/powerpoint/2010/main" val="1342891498"/>
+      </p:ext>
+    </p:extLst>
+  </p:cSld>
+  <p:clrMapOvr>
+    <a:masterClrMapping/>
+  </p:clrMapOvr>
+</p:sld>
+</file>
+
+<file path=ppt/slides/slide5.xml><?xml version="1.0" encoding="utf-8"?>
+<p:sld xmlns:a="http://schemas.openxmlformats.org/drawingml/2006/main" xmlns:r="http://schemas.openxmlformats.org/officeDocument/2006/relationships" xmlns:p="http://schemas.openxmlformats.org/presentationml/2006/main">
+  <p:cSld>
+    <p:spTree>
+      <p:nvGrpSpPr>
+        <p:cNvPr id="1" name=""/>
+        <p:cNvGrpSpPr/>
+        <p:nvPr/>
+      </p:nvGrpSpPr>
+      <p:grpSpPr>
+        <a:xfrm>
+          <a:off x="0" y="0"/>
+          <a:ext cx="0" cy="0"/>
+          <a:chOff x="0" y="0"/>
+          <a:chExt cx="0" cy="0"/>
+        </a:xfrm>
+      </p:grpSpPr>
+      <p:pic>
+        <p:nvPicPr>
+          <p:cNvPr id="5" name="Picture 4" descr="A person with a beard wearing boxing gloves&#10;&#10;AI-generated content may be incorrect.">
+            <a:extLst>
+              <a:ext uri="{FF2B5EF4-FFF2-40B4-BE49-F238E27FC236}">
+                <a16:creationId xmlns:a16="http://schemas.microsoft.com/office/drawing/2014/main" id="{D907AD15-5F89-1F71-6B19-7063D5C6FA0C}"/>
+              </a:ext>
+            </a:extLst>
+          </p:cNvPr>
+          <p:cNvPicPr>
+            <a:picLocks noChangeAspect="1"/>
+          </p:cNvPicPr>
+          <p:nvPr/>
+        </p:nvPicPr>
+        <p:blipFill rotWithShape="1">
+          <a:blip r:embed="rId2">
+            <a:extLst>
+              <a:ext uri="{28A0092B-C50C-407E-A947-70E740481C1C}">
+                <a14:useLocalDpi xmlns:a14="http://schemas.microsoft.com/office/drawing/2010/main" val="0"/>
+              </a:ext>
+            </a:extLst>
+          </a:blip>
+          <a:srcRect l="43511" r="6423"/>
+          <a:stretch>
+            <a:fillRect/>
+          </a:stretch>
+        </p:blipFill>
+        <p:spPr>
+          <a:xfrm>
+            <a:off x="2696425" y="176268"/>
+            <a:ext cx="5406913" cy="5406913"/>
+          </a:xfrm>
+          <a:prstGeom prst="rect">
+            <a:avLst/>
+          </a:prstGeom>
+        </p:spPr>
+      </p:pic>
+    </p:spTree>
+    <p:extLst>
+      <p:ext uri="{BB962C8B-B14F-4D97-AF65-F5344CB8AC3E}">
+        <p14:creationId xmlns:p14="http://schemas.microsoft.com/office/powerpoint/2010/main" val="2834849730"/>
+      </p:ext>
+    </p:extLst>
+  </p:cSld>
+  <p:clrMapOvr>
+    <a:masterClrMapping/>
+  </p:clrMapOvr>
+</p:sld>
+</file>
+
+<file path=ppt/slides/slide6.xml><?xml version="1.0" encoding="utf-8"?>
+<p:sld xmlns:a="http://schemas.openxmlformats.org/drawingml/2006/main" xmlns:r="http://schemas.openxmlformats.org/officeDocument/2006/relationships" xmlns:p="http://schemas.openxmlformats.org/presentationml/2006/main">
+  <p:cSld>
+    <p:spTree>
+      <p:nvGrpSpPr>
+        <p:cNvPr id="1" name=""/>
+        <p:cNvGrpSpPr/>
+        <p:nvPr/>
+      </p:nvGrpSpPr>
+      <p:grpSpPr>
+        <a:xfrm>
+          <a:off x="0" y="0"/>
+          <a:ext cx="0" cy="0"/>
+          <a:chOff x="0" y="0"/>
+          <a:chExt cx="0" cy="0"/>
+        </a:xfrm>
+      </p:grpSpPr>
+      <p:pic>
+        <p:nvPicPr>
+          <p:cNvPr id="5" name="Picture 4" descr="A person holding a sign&#10;&#10;AI-generated content may be incorrect.">
+            <a:extLst>
+              <a:ext uri="{FF2B5EF4-FFF2-40B4-BE49-F238E27FC236}">
+                <a16:creationId xmlns:a16="http://schemas.microsoft.com/office/drawing/2014/main" id="{D074FD70-3E70-8951-BF5D-59F889C3799D}"/>
+              </a:ext>
+            </a:extLst>
+          </p:cNvPr>
+          <p:cNvPicPr>
+            <a:picLocks noChangeAspect="1"/>
+          </p:cNvPicPr>
+          <p:nvPr/>
+        </p:nvPicPr>
+        <p:blipFill rotWithShape="1">
+          <a:blip r:embed="rId2">
+            <a:extLst>
+              <a:ext uri="{28A0092B-C50C-407E-A947-70E740481C1C}">
+                <a14:useLocalDpi xmlns:a14="http://schemas.microsoft.com/office/drawing/2010/main" val="0"/>
+              </a:ext>
+            </a:extLst>
+          </a:blip>
+          <a:srcRect l="24086" r="28866"/>
+          <a:stretch>
+            <a:fillRect/>
+          </a:stretch>
+        </p:blipFill>
+        <p:spPr>
+          <a:xfrm>
+            <a:off x="2859366" y="339209"/>
+            <a:ext cx="5081031" cy="5081031"/>
+          </a:xfrm>
+          <a:prstGeom prst="rect">
+            <a:avLst/>
+          </a:prstGeom>
+        </p:spPr>
+      </p:pic>
+    </p:spTree>
+    <p:extLst>
+      <p:ext uri="{BB962C8B-B14F-4D97-AF65-F5344CB8AC3E}">
+        <p14:creationId xmlns:p14="http://schemas.microsoft.com/office/powerpoint/2010/main" val="2896281435"/>
+      </p:ext>
+    </p:extLst>
+  </p:cSld>
+  <p:clrMapOvr>
+    <a:masterClrMapping/>
+  </p:clrMapOvr>
+</p:sld>
+</file>
+
+<file path=ppt/slides/slide7.xml><?xml version="1.0" encoding="utf-8"?>
+<p:sld xmlns:a="http://schemas.openxmlformats.org/drawingml/2006/main" xmlns:r="http://schemas.openxmlformats.org/officeDocument/2006/relationships" xmlns:p="http://schemas.openxmlformats.org/presentationml/2006/main">
+  <p:cSld>
+    <p:spTree>
+      <p:nvGrpSpPr>
+        <p:cNvPr id="1" name="">
+          <a:extLst>
+            <a:ext uri="{FF2B5EF4-FFF2-40B4-BE49-F238E27FC236}">
+              <a16:creationId xmlns:a16="http://schemas.microsoft.com/office/drawing/2014/main" id="{2E5292FE-3976-45FD-8E22-CAF91ABDE5C9}"/>
+            </a:ext>
+          </a:extLst>
+        </p:cNvPr>
+        <p:cNvGrpSpPr/>
+        <p:nvPr/>
+      </p:nvGrpSpPr>
+      <p:grpSpPr>
+        <a:xfrm>
+          <a:off x="0" y="0"/>
+          <a:ext cx="0" cy="0"/>
+          <a:chOff x="0" y="0"/>
+          <a:chExt cx="0" cy="0"/>
+        </a:xfrm>
+      </p:grpSpPr>
+      <p:pic>
+        <p:nvPicPr>
+          <p:cNvPr id="3" name="Picture 2" descr="A pile of different colored currency notes&#10;&#10;AI-generated content may be incorrect.">
+            <a:extLst>
+              <a:ext uri="{FF2B5EF4-FFF2-40B4-BE49-F238E27FC236}">
+                <a16:creationId xmlns:a16="http://schemas.microsoft.com/office/drawing/2014/main" id="{BB983B67-B091-830B-599F-83A3945CBD21}"/>
+              </a:ext>
+            </a:extLst>
+          </p:cNvPr>
+          <p:cNvPicPr>
+            <a:picLocks noChangeAspect="1"/>
+          </p:cNvPicPr>
+          <p:nvPr/>
+        </p:nvPicPr>
+        <p:blipFill rotWithShape="1">
+          <a:blip r:embed="rId2">
+            <a:extLst>
+              <a:ext uri="{28A0092B-C50C-407E-A947-70E740481C1C}">
+                <a14:useLocalDpi xmlns:a14="http://schemas.microsoft.com/office/drawing/2010/main" val="0"/>
+              </a:ext>
+            </a:extLst>
+          </a:blip>
+          <a:srcRect l="16667" r="16667"/>
+          <a:stretch>
+            <a:fillRect/>
+          </a:stretch>
+        </p:blipFill>
+        <p:spPr>
+          <a:xfrm>
+            <a:off x="2520156" y="0"/>
+            <a:ext cx="5759450" cy="5759450"/>
+          </a:xfrm>
+          <a:prstGeom prst="rect">
+            <a:avLst/>
+          </a:prstGeom>
+        </p:spPr>
+      </p:pic>
+    </p:spTree>
+    <p:extLst>
+      <p:ext uri="{BB962C8B-B14F-4D97-AF65-F5344CB8AC3E}">
+        <p14:creationId xmlns:p14="http://schemas.microsoft.com/office/powerpoint/2010/main" val="4227428215"/>
       </p:ext>
     </p:extLst>
   </p:cSld>

</xml_diff>